<commit_message>
docs: ✏️ update mockup files by replacing JPG with PNG and adding new titlescreen image
</commit_message>
<xml_diff>
--- a/docs/mockups/mockups.pptx
+++ b/docs/mockups/mockups.pptx
@@ -5,8 +5,10 @@
     <p:sldMasterId id="2147483648" r:id="rId1"/>
   </p:sldMasterIdLst>
   <p:sldIdLst>
-    <p:sldId id="257" r:id="rId2"/>
-    <p:sldId id="256" r:id="rId3"/>
+    <p:sldId id="259" r:id="rId2"/>
+    <p:sldId id="257" r:id="rId3"/>
+    <p:sldId id="256" r:id="rId4"/>
+    <p:sldId id="258" r:id="rId5"/>
   </p:sldIdLst>
   <p:sldSz cx="12192000" cy="6858000"/>
   <p:notesSz cx="6858000" cy="9144000"/>
@@ -105,6 +107,11 @@
       </a:defRPr>
     </a:lvl9pPr>
   </p:defaultTextStyle>
+  <p:extLst>
+    <p:ext uri="{EFAFB233-063F-42B5-8137-9DF3F51BA10A}">
+      <p15:sldGuideLst xmlns:p15="http://schemas.microsoft.com/office/powerpoint/2012/main"/>
+    </p:ext>
+  </p:extLst>
 </p:presentation>
 </file>
 
@@ -2965,6 +2972,117 @@
           <a:chExt cx="0" cy="0"/>
         </a:xfrm>
       </p:grpSpPr>
+      <p:sp>
+        <p:nvSpPr>
+          <p:cNvPr id="5" name="Rectangle 4"/>
+          <p:cNvSpPr/>
+          <p:nvPr/>
+        </p:nvSpPr>
+        <p:spPr>
+          <a:xfrm>
+            <a:off x="0" y="0"/>
+            <a:ext cx="12192000" cy="6858000"/>
+          </a:xfrm>
+          <a:prstGeom prst="rect">
+            <a:avLst/>
+          </a:prstGeom>
+        </p:spPr>
+        <p:style>
+          <a:lnRef idx="1">
+            <a:schemeClr val="accent3"/>
+          </a:lnRef>
+          <a:fillRef idx="3">
+            <a:schemeClr val="accent3"/>
+          </a:fillRef>
+          <a:effectRef idx="2">
+            <a:schemeClr val="accent3"/>
+          </a:effectRef>
+          <a:fontRef idx="minor">
+            <a:schemeClr val="lt1"/>
+          </a:fontRef>
+        </p:style>
+        <p:txBody>
+          <a:bodyPr rtlCol="0" anchor="ctr"/>
+          <a:lstStyle/>
+          <a:p>
+            <a:pPr algn="ctr"/>
+            <a:endParaRPr lang="en-US"/>
+          </a:p>
+        </p:txBody>
+      </p:sp>
+      <p:pic>
+        <p:nvPicPr>
+          <p:cNvPr id="4" name="Picture 3"/>
+          <p:cNvPicPr>
+            <a:picLocks noChangeAspect="1"/>
+          </p:cNvPicPr>
+          <p:nvPr/>
+        </p:nvPicPr>
+        <p:blipFill>
+          <a:blip r:embed="rId2" cstate="print">
+            <a:extLst>
+              <a:ext uri="{28A0092B-C50C-407E-A947-70E740481C1C}">
+                <a14:useLocalDpi xmlns:a14="http://schemas.microsoft.com/office/drawing/2010/main" val="0"/>
+              </a:ext>
+            </a:extLst>
+          </a:blip>
+          <a:stretch>
+            <a:fillRect/>
+          </a:stretch>
+        </p:blipFill>
+        <p:spPr>
+          <a:xfrm>
+            <a:off x="5091768" y="2424768"/>
+            <a:ext cx="2008464" cy="2008464"/>
+          </a:xfrm>
+          <a:prstGeom prst="roundRect">
+            <a:avLst>
+              <a:gd name="adj" fmla="val 8594"/>
+            </a:avLst>
+          </a:prstGeom>
+          <a:solidFill>
+            <a:srgbClr val="FFFFFF">
+              <a:shade val="85000"/>
+            </a:srgbClr>
+          </a:solidFill>
+          <a:ln>
+            <a:noFill/>
+          </a:ln>
+          <a:effectLst>
+            <a:reflection blurRad="12700" stA="38000" endPos="28000" dist="5000" dir="5400000" sy="-100000" algn="bl" rotWithShape="0"/>
+          </a:effectLst>
+        </p:spPr>
+      </p:pic>
+    </p:spTree>
+    <p:extLst>
+      <p:ext uri="{BB962C8B-B14F-4D97-AF65-F5344CB8AC3E}">
+        <p14:creationId xmlns:p14="http://schemas.microsoft.com/office/powerpoint/2010/main" val="2537244390"/>
+      </p:ext>
+    </p:extLst>
+  </p:cSld>
+  <p:clrMapOvr>
+    <a:masterClrMapping/>
+  </p:clrMapOvr>
+</p:sld>
+</file>
+
+<file path=ppt/slides/slide2.xml><?xml version="1.0" encoding="utf-8"?>
+<p:sld xmlns:a="http://schemas.openxmlformats.org/drawingml/2006/main" xmlns:r="http://schemas.openxmlformats.org/officeDocument/2006/relationships" xmlns:p="http://schemas.openxmlformats.org/presentationml/2006/main">
+  <p:cSld>
+    <p:spTree>
+      <p:nvGrpSpPr>
+        <p:cNvPr id="1" name=""/>
+        <p:cNvGrpSpPr/>
+        <p:nvPr/>
+      </p:nvGrpSpPr>
+      <p:grpSpPr>
+        <a:xfrm>
+          <a:off x="0" y="0"/>
+          <a:ext cx="0" cy="0"/>
+          <a:chOff x="0" y="0"/>
+          <a:chExt cx="0" cy="0"/>
+        </a:xfrm>
+      </p:grpSpPr>
       <p:pic>
         <p:nvPicPr>
           <p:cNvPr id="4" name="Picture 3"/>
@@ -4224,7 +4342,7 @@
 </p:sld>
 </file>
 
-<file path=ppt/slides/slide2.xml><?xml version="1.0" encoding="utf-8"?>
+<file path=ppt/slides/slide3.xml><?xml version="1.0" encoding="utf-8"?>
 <p:sld xmlns:a="http://schemas.openxmlformats.org/drawingml/2006/main" xmlns:r="http://schemas.openxmlformats.org/officeDocument/2006/relationships" xmlns:p="http://schemas.openxmlformats.org/presentationml/2006/main">
   <p:cSld>
     <p:spTree>
@@ -4576,6 +4694,1149 @@
     <p:extLst>
       <p:ext uri="{BB962C8B-B14F-4D97-AF65-F5344CB8AC3E}">
         <p14:creationId xmlns:p14="http://schemas.microsoft.com/office/powerpoint/2010/main" val="2533066476"/>
+      </p:ext>
+    </p:extLst>
+  </p:cSld>
+  <p:clrMapOvr>
+    <a:masterClrMapping/>
+  </p:clrMapOvr>
+</p:sld>
+</file>
+
+<file path=ppt/slides/slide4.xml><?xml version="1.0" encoding="utf-8"?>
+<p:sld xmlns:a="http://schemas.openxmlformats.org/drawingml/2006/main" xmlns:r="http://schemas.openxmlformats.org/officeDocument/2006/relationships" xmlns:p="http://schemas.openxmlformats.org/presentationml/2006/main">
+  <p:cSld>
+    <p:spTree>
+      <p:nvGrpSpPr>
+        <p:cNvPr id="1" name=""/>
+        <p:cNvGrpSpPr/>
+        <p:nvPr/>
+      </p:nvGrpSpPr>
+      <p:grpSpPr>
+        <a:xfrm>
+          <a:off x="0" y="0"/>
+          <a:ext cx="0" cy="0"/>
+          <a:chOff x="0" y="0"/>
+          <a:chExt cx="0" cy="0"/>
+        </a:xfrm>
+      </p:grpSpPr>
+      <p:pic>
+        <p:nvPicPr>
+          <p:cNvPr id="37" name="Picture 36"/>
+          <p:cNvPicPr>
+            <a:picLocks noChangeAspect="1"/>
+          </p:cNvPicPr>
+          <p:nvPr/>
+        </p:nvPicPr>
+        <p:blipFill>
+          <a:blip r:embed="rId2"/>
+          <a:stretch>
+            <a:fillRect/>
+          </a:stretch>
+        </p:blipFill>
+        <p:spPr>
+          <a:xfrm>
+            <a:off x="847862" y="-3056"/>
+            <a:ext cx="10159642" cy="6861056"/>
+          </a:xfrm>
+          <a:prstGeom prst="rect">
+            <a:avLst/>
+          </a:prstGeom>
+        </p:spPr>
+      </p:pic>
+      <p:sp>
+        <p:nvSpPr>
+          <p:cNvPr id="39" name="Rectangle 38"/>
+          <p:cNvSpPr/>
+          <p:nvPr/>
+        </p:nvSpPr>
+        <p:spPr>
+          <a:xfrm>
+            <a:off x="0" y="0"/>
+            <a:ext cx="12192000" cy="6858000"/>
+          </a:xfrm>
+          <a:prstGeom prst="rect">
+            <a:avLst/>
+          </a:prstGeom>
+        </p:spPr>
+        <p:style>
+          <a:lnRef idx="1">
+            <a:schemeClr val="accent3"/>
+          </a:lnRef>
+          <a:fillRef idx="3">
+            <a:schemeClr val="accent3"/>
+          </a:fillRef>
+          <a:effectRef idx="2">
+            <a:schemeClr val="accent3"/>
+          </a:effectRef>
+          <a:fontRef idx="minor">
+            <a:schemeClr val="lt1"/>
+          </a:fontRef>
+        </p:style>
+        <p:txBody>
+          <a:bodyPr rtlCol="0" anchor="ctr"/>
+          <a:lstStyle/>
+          <a:p>
+            <a:pPr algn="ctr"/>
+            <a:endParaRPr lang="en-US"/>
+          </a:p>
+        </p:txBody>
+      </p:sp>
+      <p:sp>
+        <p:nvSpPr>
+          <p:cNvPr id="5" name="Rounded Rectangle 4"/>
+          <p:cNvSpPr/>
+          <p:nvPr/>
+        </p:nvSpPr>
+        <p:spPr>
+          <a:xfrm>
+            <a:off x="11115413" y="180094"/>
+            <a:ext cx="838896" cy="729841"/>
+          </a:xfrm>
+          <a:prstGeom prst="roundRect">
+            <a:avLst/>
+          </a:prstGeom>
+        </p:spPr>
+        <p:style>
+          <a:lnRef idx="0">
+            <a:schemeClr val="accent2"/>
+          </a:lnRef>
+          <a:fillRef idx="3">
+            <a:schemeClr val="accent2"/>
+          </a:fillRef>
+          <a:effectRef idx="3">
+            <a:schemeClr val="accent2"/>
+          </a:effectRef>
+          <a:fontRef idx="minor">
+            <a:schemeClr val="lt1"/>
+          </a:fontRef>
+        </p:style>
+        <p:txBody>
+          <a:bodyPr rtlCol="0" anchor="ctr"/>
+          <a:lstStyle/>
+          <a:p>
+            <a:pPr algn="ctr"/>
+            <a:r>
+              <a:rPr lang="en-US" sz="2400" b="1" dirty="0" smtClean="0"/>
+              <a:t>X</a:t>
+            </a:r>
+            <a:endParaRPr lang="en-US" sz="2400" b="1" dirty="0"/>
+          </a:p>
+        </p:txBody>
+      </p:sp>
+      <p:sp>
+        <p:nvSpPr>
+          <p:cNvPr id="7" name="Rectangle 6"/>
+          <p:cNvSpPr/>
+          <p:nvPr/>
+        </p:nvSpPr>
+        <p:spPr>
+          <a:xfrm>
+            <a:off x="3970198" y="83350"/>
+            <a:ext cx="4013919" cy="923330"/>
+          </a:xfrm>
+          <a:prstGeom prst="rect">
+            <a:avLst/>
+          </a:prstGeom>
+          <a:noFill/>
+        </p:spPr>
+        <p:txBody>
+          <a:bodyPr wrap="none" lIns="91440" tIns="45720" rIns="91440" bIns="45720">
+            <a:spAutoFit/>
+            <a:scene3d>
+              <a:camera prst="orthographicFront"/>
+              <a:lightRig rig="soft" dir="t">
+                <a:rot lat="0" lon="0" rev="15600000"/>
+              </a:lightRig>
+            </a:scene3d>
+            <a:sp3d extrusionH="57150" prstMaterial="softEdge">
+              <a:bevelT w="25400" h="38100"/>
+            </a:sp3d>
+          </a:bodyPr>
+          <a:lstStyle/>
+          <a:p>
+            <a:pPr algn="ctr"/>
+            <a:r>
+              <a:rPr lang="en-US" sz="5400" b="1" cap="none" spc="0" dirty="0" smtClean="0">
+                <a:ln/>
+                <a:solidFill>
+                  <a:schemeClr val="accent4"/>
+                </a:solidFill>
+                <a:effectLst/>
+              </a:rPr>
+              <a:t>SELECT LEVEL</a:t>
+            </a:r>
+            <a:endParaRPr lang="en-US" sz="5400" b="1" cap="none" spc="0" dirty="0" smtClean="0">
+              <a:ln/>
+              <a:solidFill>
+                <a:schemeClr val="accent4"/>
+              </a:solidFill>
+              <a:effectLst/>
+            </a:endParaRPr>
+          </a:p>
+        </p:txBody>
+      </p:sp>
+      <p:sp>
+        <p:nvSpPr>
+          <p:cNvPr id="8" name="Rounded Rectangle 7"/>
+          <p:cNvSpPr/>
+          <p:nvPr/>
+        </p:nvSpPr>
+        <p:spPr>
+          <a:xfrm>
+            <a:off x="1157681" y="3181274"/>
+            <a:ext cx="619830" cy="1201858"/>
+          </a:xfrm>
+          <a:prstGeom prst="roundRect">
+            <a:avLst/>
+          </a:prstGeom>
+        </p:spPr>
+        <p:style>
+          <a:lnRef idx="0">
+            <a:schemeClr val="accent6"/>
+          </a:lnRef>
+          <a:fillRef idx="3">
+            <a:schemeClr val="accent6"/>
+          </a:fillRef>
+          <a:effectRef idx="3">
+            <a:schemeClr val="accent6"/>
+          </a:effectRef>
+          <a:fontRef idx="minor">
+            <a:schemeClr val="lt1"/>
+          </a:fontRef>
+        </p:style>
+        <p:txBody>
+          <a:bodyPr rtlCol="0" anchor="ctr"/>
+          <a:lstStyle/>
+          <a:p>
+            <a:pPr algn="ctr"/>
+            <a:r>
+              <a:rPr lang="en-US" sz="2400" b="1" dirty="0" smtClean="0"/>
+              <a:t>&lt;&lt;</a:t>
+            </a:r>
+            <a:endParaRPr lang="en-US" sz="2400" b="1" dirty="0"/>
+          </a:p>
+        </p:txBody>
+      </p:sp>
+      <p:sp>
+        <p:nvSpPr>
+          <p:cNvPr id="9" name="Rounded Rectangle 8"/>
+          <p:cNvSpPr/>
+          <p:nvPr/>
+        </p:nvSpPr>
+        <p:spPr>
+          <a:xfrm>
+            <a:off x="10200959" y="3181274"/>
+            <a:ext cx="688992" cy="1213094"/>
+          </a:xfrm>
+          <a:prstGeom prst="roundRect">
+            <a:avLst/>
+          </a:prstGeom>
+        </p:spPr>
+        <p:style>
+          <a:lnRef idx="0">
+            <a:schemeClr val="accent6"/>
+          </a:lnRef>
+          <a:fillRef idx="3">
+            <a:schemeClr val="accent6"/>
+          </a:fillRef>
+          <a:effectRef idx="3">
+            <a:schemeClr val="accent6"/>
+          </a:effectRef>
+          <a:fontRef idx="minor">
+            <a:schemeClr val="lt1"/>
+          </a:fontRef>
+        </p:style>
+        <p:txBody>
+          <a:bodyPr rtlCol="0" anchor="ctr"/>
+          <a:lstStyle/>
+          <a:p>
+            <a:pPr algn="ctr"/>
+            <a:r>
+              <a:rPr lang="en-US" sz="2400" b="1" dirty="0" smtClean="0"/>
+              <a:t>&gt;&gt;</a:t>
+            </a:r>
+            <a:endParaRPr lang="en-US" sz="2400" b="1" dirty="0"/>
+          </a:p>
+        </p:txBody>
+      </p:sp>
+      <p:grpSp>
+        <p:nvGrpSpPr>
+          <p:cNvPr id="38" name="Group 37"/>
+          <p:cNvGrpSpPr/>
+          <p:nvPr/>
+        </p:nvGrpSpPr>
+        <p:grpSpPr>
+          <a:xfrm>
+            <a:off x="2138184" y="1067757"/>
+            <a:ext cx="7702102" cy="5072983"/>
+            <a:chOff x="2889645" y="1483831"/>
+            <a:chExt cx="6286068" cy="4514297"/>
+          </a:xfrm>
+        </p:grpSpPr>
+        <p:sp>
+          <p:nvSpPr>
+            <p:cNvPr id="10" name="Rounded Rectangle 9"/>
+            <p:cNvSpPr/>
+            <p:nvPr/>
+          </p:nvSpPr>
+          <p:spPr>
+            <a:xfrm>
+              <a:off x="2889645" y="1820303"/>
+              <a:ext cx="1035017" cy="1089495"/>
+            </a:xfrm>
+            <a:prstGeom prst="roundRect">
+              <a:avLst/>
+            </a:prstGeom>
+          </p:spPr>
+          <p:style>
+            <a:lnRef idx="0">
+              <a:schemeClr val="accent1"/>
+            </a:lnRef>
+            <a:fillRef idx="3">
+              <a:schemeClr val="accent1"/>
+            </a:fillRef>
+            <a:effectRef idx="3">
+              <a:schemeClr val="accent1"/>
+            </a:effectRef>
+            <a:fontRef idx="minor">
+              <a:schemeClr val="lt1"/>
+            </a:fontRef>
+          </p:style>
+          <p:txBody>
+            <a:bodyPr rtlCol="0" anchor="ctr"/>
+            <a:lstStyle/>
+            <a:p>
+              <a:pPr algn="ctr"/>
+              <a:r>
+                <a:rPr lang="en-US" sz="2400" b="1" dirty="0" smtClean="0"/>
+                <a:t>1</a:t>
+              </a:r>
+              <a:endParaRPr lang="en-US" sz="2400" b="1" dirty="0"/>
+            </a:p>
+          </p:txBody>
+        </p:sp>
+        <p:sp>
+          <p:nvSpPr>
+            <p:cNvPr id="11" name="Rounded Rectangle 10"/>
+            <p:cNvSpPr/>
+            <p:nvPr/>
+          </p:nvSpPr>
+          <p:spPr>
+            <a:xfrm>
+              <a:off x="2889645" y="3354589"/>
+              <a:ext cx="1035017" cy="1089495"/>
+            </a:xfrm>
+            <a:prstGeom prst="roundRect">
+              <a:avLst/>
+            </a:prstGeom>
+          </p:spPr>
+          <p:style>
+            <a:lnRef idx="0">
+              <a:schemeClr val="accent5"/>
+            </a:lnRef>
+            <a:fillRef idx="3">
+              <a:schemeClr val="accent5"/>
+            </a:fillRef>
+            <a:effectRef idx="3">
+              <a:schemeClr val="accent5"/>
+            </a:effectRef>
+            <a:fontRef idx="minor">
+              <a:schemeClr val="lt1"/>
+            </a:fontRef>
+          </p:style>
+          <p:txBody>
+            <a:bodyPr rtlCol="0" anchor="ctr"/>
+            <a:lstStyle/>
+            <a:p>
+              <a:pPr algn="ctr"/>
+              <a:r>
+                <a:rPr lang="en-US" sz="2400" b="1" dirty="0"/>
+                <a:t>?</a:t>
+              </a:r>
+              <a:endParaRPr lang="en-US" sz="2400" b="1" dirty="0"/>
+            </a:p>
+          </p:txBody>
+        </p:sp>
+        <p:sp>
+          <p:nvSpPr>
+            <p:cNvPr id="12" name="Rounded Rectangle 11"/>
+            <p:cNvSpPr/>
+            <p:nvPr/>
+          </p:nvSpPr>
+          <p:spPr>
+            <a:xfrm>
+              <a:off x="4219024" y="1823798"/>
+              <a:ext cx="1035017" cy="1089495"/>
+            </a:xfrm>
+            <a:prstGeom prst="roundRect">
+              <a:avLst/>
+            </a:prstGeom>
+          </p:spPr>
+          <p:style>
+            <a:lnRef idx="0">
+              <a:schemeClr val="accent1"/>
+            </a:lnRef>
+            <a:fillRef idx="3">
+              <a:schemeClr val="accent1"/>
+            </a:fillRef>
+            <a:effectRef idx="3">
+              <a:schemeClr val="accent1"/>
+            </a:effectRef>
+            <a:fontRef idx="minor">
+              <a:schemeClr val="lt1"/>
+            </a:fontRef>
+          </p:style>
+          <p:txBody>
+            <a:bodyPr rtlCol="0" anchor="ctr"/>
+            <a:lstStyle/>
+            <a:p>
+              <a:pPr algn="ctr"/>
+              <a:r>
+                <a:rPr lang="en-US" sz="2400" b="1" dirty="0" smtClean="0"/>
+                <a:t>2</a:t>
+              </a:r>
+              <a:endParaRPr lang="en-US" sz="2400" b="1" dirty="0"/>
+            </a:p>
+          </p:txBody>
+        </p:sp>
+        <p:sp>
+          <p:nvSpPr>
+            <p:cNvPr id="13" name="Rounded Rectangle 12"/>
+            <p:cNvSpPr/>
+            <p:nvPr/>
+          </p:nvSpPr>
+          <p:spPr>
+            <a:xfrm>
+              <a:off x="4219024" y="3344590"/>
+              <a:ext cx="1035017" cy="1089495"/>
+            </a:xfrm>
+            <a:prstGeom prst="roundRect">
+              <a:avLst/>
+            </a:prstGeom>
+          </p:spPr>
+          <p:style>
+            <a:lnRef idx="0">
+              <a:schemeClr val="accent5"/>
+            </a:lnRef>
+            <a:fillRef idx="3">
+              <a:schemeClr val="accent5"/>
+            </a:fillRef>
+            <a:effectRef idx="3">
+              <a:schemeClr val="accent5"/>
+            </a:effectRef>
+            <a:fontRef idx="minor">
+              <a:schemeClr val="lt1"/>
+            </a:fontRef>
+          </p:style>
+          <p:txBody>
+            <a:bodyPr rtlCol="0" anchor="ctr"/>
+            <a:lstStyle/>
+            <a:p>
+              <a:pPr algn="ctr"/>
+              <a:r>
+                <a:rPr lang="en-US" sz="2400" b="1" dirty="0"/>
+                <a:t>?</a:t>
+              </a:r>
+              <a:endParaRPr lang="en-US" sz="2400" b="1" dirty="0"/>
+            </a:p>
+          </p:txBody>
+        </p:sp>
+        <p:sp>
+          <p:nvSpPr>
+            <p:cNvPr id="15" name="5-Point Star 14"/>
+            <p:cNvSpPr/>
+            <p:nvPr/>
+          </p:nvSpPr>
+          <p:spPr>
+            <a:xfrm>
+              <a:off x="3245728" y="1492798"/>
+              <a:ext cx="329180" cy="314853"/>
+            </a:xfrm>
+            <a:prstGeom prst="star5">
+              <a:avLst/>
+            </a:prstGeom>
+          </p:spPr>
+          <p:style>
+            <a:lnRef idx="1">
+              <a:schemeClr val="accent4"/>
+            </a:lnRef>
+            <a:fillRef idx="3">
+              <a:schemeClr val="accent4"/>
+            </a:fillRef>
+            <a:effectRef idx="2">
+              <a:schemeClr val="accent4"/>
+            </a:effectRef>
+            <a:fontRef idx="minor">
+              <a:schemeClr val="lt1"/>
+            </a:fontRef>
+          </p:style>
+          <p:txBody>
+            <a:bodyPr rtlCol="0" anchor="ctr"/>
+            <a:lstStyle/>
+            <a:p>
+              <a:pPr algn="ctr"/>
+              <a:endParaRPr lang="en-US"/>
+            </a:p>
+          </p:txBody>
+        </p:sp>
+        <p:sp>
+          <p:nvSpPr>
+            <p:cNvPr id="16" name="5-Point Star 15"/>
+            <p:cNvSpPr/>
+            <p:nvPr/>
+          </p:nvSpPr>
+          <p:spPr>
+            <a:xfrm>
+              <a:off x="3527431" y="1595250"/>
+              <a:ext cx="207003" cy="217899"/>
+            </a:xfrm>
+            <a:prstGeom prst="star5">
+              <a:avLst/>
+            </a:prstGeom>
+          </p:spPr>
+          <p:style>
+            <a:lnRef idx="1">
+              <a:schemeClr val="accent4"/>
+            </a:lnRef>
+            <a:fillRef idx="3">
+              <a:schemeClr val="accent4"/>
+            </a:fillRef>
+            <a:effectRef idx="2">
+              <a:schemeClr val="accent4"/>
+            </a:effectRef>
+            <a:fontRef idx="minor">
+              <a:schemeClr val="lt1"/>
+            </a:fontRef>
+          </p:style>
+          <p:txBody>
+            <a:bodyPr rtlCol="0" anchor="ctr"/>
+            <a:lstStyle/>
+            <a:p>
+              <a:pPr algn="ctr"/>
+              <a:endParaRPr lang="en-US"/>
+            </a:p>
+          </p:txBody>
+        </p:sp>
+        <p:sp>
+          <p:nvSpPr>
+            <p:cNvPr id="17" name="5-Point Star 16"/>
+            <p:cNvSpPr/>
+            <p:nvPr/>
+          </p:nvSpPr>
+          <p:spPr>
+            <a:xfrm>
+              <a:off x="3072026" y="1588252"/>
+              <a:ext cx="207003" cy="217899"/>
+            </a:xfrm>
+            <a:prstGeom prst="star5">
+              <a:avLst/>
+            </a:prstGeom>
+          </p:spPr>
+          <p:style>
+            <a:lnRef idx="1">
+              <a:schemeClr val="accent4"/>
+            </a:lnRef>
+            <a:fillRef idx="3">
+              <a:schemeClr val="accent4"/>
+            </a:fillRef>
+            <a:effectRef idx="2">
+              <a:schemeClr val="accent4"/>
+            </a:effectRef>
+            <a:fontRef idx="minor">
+              <a:schemeClr val="lt1"/>
+            </a:fontRef>
+          </p:style>
+          <p:txBody>
+            <a:bodyPr rtlCol="0" anchor="ctr"/>
+            <a:lstStyle/>
+            <a:p>
+              <a:pPr algn="ctr"/>
+              <a:endParaRPr lang="en-US"/>
+            </a:p>
+          </p:txBody>
+        </p:sp>
+        <p:sp>
+          <p:nvSpPr>
+            <p:cNvPr id="21" name="Rounded Rectangle 20"/>
+            <p:cNvSpPr/>
+            <p:nvPr/>
+          </p:nvSpPr>
+          <p:spPr>
+            <a:xfrm>
+              <a:off x="2889645" y="4888876"/>
+              <a:ext cx="1035017" cy="1089495"/>
+            </a:xfrm>
+            <a:prstGeom prst="roundRect">
+              <a:avLst/>
+            </a:prstGeom>
+          </p:spPr>
+          <p:style>
+            <a:lnRef idx="0">
+              <a:schemeClr val="accent5"/>
+            </a:lnRef>
+            <a:fillRef idx="3">
+              <a:schemeClr val="accent5"/>
+            </a:fillRef>
+            <a:effectRef idx="3">
+              <a:schemeClr val="accent5"/>
+            </a:effectRef>
+            <a:fontRef idx="minor">
+              <a:schemeClr val="lt1"/>
+            </a:fontRef>
+          </p:style>
+          <p:txBody>
+            <a:bodyPr rtlCol="0" anchor="ctr"/>
+            <a:lstStyle/>
+            <a:p>
+              <a:pPr algn="ctr"/>
+              <a:r>
+                <a:rPr lang="en-US" sz="2400" b="1" dirty="0"/>
+                <a:t>?</a:t>
+              </a:r>
+              <a:endParaRPr lang="en-US" sz="2400" b="1" dirty="0"/>
+            </a:p>
+          </p:txBody>
+        </p:sp>
+        <p:sp>
+          <p:nvSpPr>
+            <p:cNvPr id="22" name="5-Point Star 21"/>
+            <p:cNvSpPr/>
+            <p:nvPr/>
+          </p:nvSpPr>
+          <p:spPr>
+            <a:xfrm>
+              <a:off x="4546621" y="1483831"/>
+              <a:ext cx="329180" cy="314853"/>
+            </a:xfrm>
+            <a:prstGeom prst="star5">
+              <a:avLst/>
+            </a:prstGeom>
+          </p:spPr>
+          <p:style>
+            <a:lnRef idx="1">
+              <a:schemeClr val="accent4"/>
+            </a:lnRef>
+            <a:fillRef idx="3">
+              <a:schemeClr val="accent4"/>
+            </a:fillRef>
+            <a:effectRef idx="2">
+              <a:schemeClr val="accent4"/>
+            </a:effectRef>
+            <a:fontRef idx="minor">
+              <a:schemeClr val="lt1"/>
+            </a:fontRef>
+          </p:style>
+          <p:txBody>
+            <a:bodyPr rtlCol="0" anchor="ctr"/>
+            <a:lstStyle/>
+            <a:p>
+              <a:pPr algn="ctr"/>
+              <a:endParaRPr lang="en-US"/>
+            </a:p>
+          </p:txBody>
+        </p:sp>
+        <p:sp>
+          <p:nvSpPr>
+            <p:cNvPr id="24" name="5-Point Star 23"/>
+            <p:cNvSpPr/>
+            <p:nvPr/>
+          </p:nvSpPr>
+          <p:spPr>
+            <a:xfrm>
+              <a:off x="4372919" y="1579283"/>
+              <a:ext cx="207003" cy="217899"/>
+            </a:xfrm>
+            <a:prstGeom prst="star5">
+              <a:avLst/>
+            </a:prstGeom>
+          </p:spPr>
+          <p:style>
+            <a:lnRef idx="1">
+              <a:schemeClr val="accent4"/>
+            </a:lnRef>
+            <a:fillRef idx="3">
+              <a:schemeClr val="accent4"/>
+            </a:fillRef>
+            <a:effectRef idx="2">
+              <a:schemeClr val="accent4"/>
+            </a:effectRef>
+            <a:fontRef idx="minor">
+              <a:schemeClr val="lt1"/>
+            </a:fontRef>
+          </p:style>
+          <p:txBody>
+            <a:bodyPr rtlCol="0" anchor="ctr"/>
+            <a:lstStyle/>
+            <a:p>
+              <a:pPr algn="ctr"/>
+              <a:endParaRPr lang="en-US"/>
+            </a:p>
+          </p:txBody>
+        </p:sp>
+        <p:sp>
+          <p:nvSpPr>
+            <p:cNvPr id="25" name="Rounded Rectangle 24"/>
+            <p:cNvSpPr/>
+            <p:nvPr/>
+          </p:nvSpPr>
+          <p:spPr>
+            <a:xfrm>
+              <a:off x="5548404" y="1820303"/>
+              <a:ext cx="1035017" cy="1089495"/>
+            </a:xfrm>
+            <a:prstGeom prst="roundRect">
+              <a:avLst/>
+            </a:prstGeom>
+          </p:spPr>
+          <p:style>
+            <a:lnRef idx="0">
+              <a:schemeClr val="accent1"/>
+            </a:lnRef>
+            <a:fillRef idx="3">
+              <a:schemeClr val="accent1"/>
+            </a:fillRef>
+            <a:effectRef idx="3">
+              <a:schemeClr val="accent1"/>
+            </a:effectRef>
+            <a:fontRef idx="minor">
+              <a:schemeClr val="lt1"/>
+            </a:fontRef>
+          </p:style>
+          <p:txBody>
+            <a:bodyPr rtlCol="0" anchor="ctr"/>
+            <a:lstStyle/>
+            <a:p>
+              <a:pPr algn="ctr"/>
+              <a:r>
+                <a:rPr lang="en-US" sz="2400" b="1" dirty="0" smtClean="0"/>
+                <a:t>3</a:t>
+              </a:r>
+              <a:endParaRPr lang="en-US" sz="2400" b="1" dirty="0"/>
+            </a:p>
+          </p:txBody>
+        </p:sp>
+        <p:sp>
+          <p:nvSpPr>
+            <p:cNvPr id="26" name="Rounded Rectangle 25"/>
+            <p:cNvSpPr/>
+            <p:nvPr/>
+          </p:nvSpPr>
+          <p:spPr>
+            <a:xfrm>
+              <a:off x="6844550" y="1820303"/>
+              <a:ext cx="1035017" cy="1089495"/>
+            </a:xfrm>
+            <a:prstGeom prst="roundRect">
+              <a:avLst/>
+            </a:prstGeom>
+          </p:spPr>
+          <p:style>
+            <a:lnRef idx="0">
+              <a:schemeClr val="accent5"/>
+            </a:lnRef>
+            <a:fillRef idx="3">
+              <a:schemeClr val="accent5"/>
+            </a:fillRef>
+            <a:effectRef idx="3">
+              <a:schemeClr val="accent5"/>
+            </a:effectRef>
+            <a:fontRef idx="minor">
+              <a:schemeClr val="lt1"/>
+            </a:fontRef>
+          </p:style>
+          <p:txBody>
+            <a:bodyPr rtlCol="0" anchor="ctr"/>
+            <a:lstStyle/>
+            <a:p>
+              <a:pPr algn="ctr"/>
+              <a:r>
+                <a:rPr lang="en-US" sz="2400" b="1" dirty="0" smtClean="0"/>
+                <a:t>?</a:t>
+              </a:r>
+              <a:endParaRPr lang="en-US" sz="2400" b="1" dirty="0"/>
+            </a:p>
+          </p:txBody>
+        </p:sp>
+        <p:sp>
+          <p:nvSpPr>
+            <p:cNvPr id="27" name="Rounded Rectangle 26"/>
+            <p:cNvSpPr/>
+            <p:nvPr/>
+          </p:nvSpPr>
+          <p:spPr>
+            <a:xfrm>
+              <a:off x="8140696" y="1808802"/>
+              <a:ext cx="1035017" cy="1089495"/>
+            </a:xfrm>
+            <a:prstGeom prst="roundRect">
+              <a:avLst/>
+            </a:prstGeom>
+          </p:spPr>
+          <p:style>
+            <a:lnRef idx="0">
+              <a:schemeClr val="accent5"/>
+            </a:lnRef>
+            <a:fillRef idx="3">
+              <a:schemeClr val="accent5"/>
+            </a:fillRef>
+            <a:effectRef idx="3">
+              <a:schemeClr val="accent5"/>
+            </a:effectRef>
+            <a:fontRef idx="minor">
+              <a:schemeClr val="lt1"/>
+            </a:fontRef>
+          </p:style>
+          <p:txBody>
+            <a:bodyPr rtlCol="0" anchor="ctr"/>
+            <a:lstStyle/>
+            <a:p>
+              <a:pPr algn="ctr"/>
+              <a:r>
+                <a:rPr lang="en-US" sz="2400" b="1" dirty="0"/>
+                <a:t>?</a:t>
+              </a:r>
+              <a:endParaRPr lang="en-US" sz="2400" b="1" dirty="0"/>
+            </a:p>
+          </p:txBody>
+        </p:sp>
+        <p:sp>
+          <p:nvSpPr>
+            <p:cNvPr id="28" name="Rounded Rectangle 27"/>
+            <p:cNvSpPr/>
+            <p:nvPr/>
+          </p:nvSpPr>
+          <p:spPr>
+            <a:xfrm>
+              <a:off x="5548404" y="3357842"/>
+              <a:ext cx="1035017" cy="1089495"/>
+            </a:xfrm>
+            <a:prstGeom prst="roundRect">
+              <a:avLst/>
+            </a:prstGeom>
+          </p:spPr>
+          <p:style>
+            <a:lnRef idx="0">
+              <a:schemeClr val="accent5"/>
+            </a:lnRef>
+            <a:fillRef idx="3">
+              <a:schemeClr val="accent5"/>
+            </a:fillRef>
+            <a:effectRef idx="3">
+              <a:schemeClr val="accent5"/>
+            </a:effectRef>
+            <a:fontRef idx="minor">
+              <a:schemeClr val="lt1"/>
+            </a:fontRef>
+          </p:style>
+          <p:txBody>
+            <a:bodyPr rtlCol="0" anchor="ctr"/>
+            <a:lstStyle/>
+            <a:p>
+              <a:pPr algn="ctr"/>
+              <a:r>
+                <a:rPr lang="en-US" sz="2400" b="1" dirty="0"/>
+                <a:t>?</a:t>
+              </a:r>
+              <a:endParaRPr lang="en-US" sz="2400" b="1" dirty="0"/>
+            </a:p>
+          </p:txBody>
+        </p:sp>
+        <p:sp>
+          <p:nvSpPr>
+            <p:cNvPr id="29" name="Rounded Rectangle 28"/>
+            <p:cNvSpPr/>
+            <p:nvPr/>
+          </p:nvSpPr>
+          <p:spPr>
+            <a:xfrm>
+              <a:off x="6844550" y="3357842"/>
+              <a:ext cx="1035017" cy="1089495"/>
+            </a:xfrm>
+            <a:prstGeom prst="roundRect">
+              <a:avLst/>
+            </a:prstGeom>
+          </p:spPr>
+          <p:style>
+            <a:lnRef idx="0">
+              <a:schemeClr val="accent5"/>
+            </a:lnRef>
+            <a:fillRef idx="3">
+              <a:schemeClr val="accent5"/>
+            </a:fillRef>
+            <a:effectRef idx="3">
+              <a:schemeClr val="accent5"/>
+            </a:effectRef>
+            <a:fontRef idx="minor">
+              <a:schemeClr val="lt1"/>
+            </a:fontRef>
+          </p:style>
+          <p:txBody>
+            <a:bodyPr rtlCol="0" anchor="ctr"/>
+            <a:lstStyle/>
+            <a:p>
+              <a:pPr algn="ctr"/>
+              <a:r>
+                <a:rPr lang="en-US" sz="2400" b="1" dirty="0"/>
+                <a:t>?</a:t>
+              </a:r>
+              <a:endParaRPr lang="en-US" sz="2400" b="1" dirty="0"/>
+            </a:p>
+          </p:txBody>
+        </p:sp>
+        <p:sp>
+          <p:nvSpPr>
+            <p:cNvPr id="30" name="Rounded Rectangle 29"/>
+            <p:cNvSpPr/>
+            <p:nvPr/>
+          </p:nvSpPr>
+          <p:spPr>
+            <a:xfrm>
+              <a:off x="8140696" y="3346341"/>
+              <a:ext cx="1035017" cy="1089495"/>
+            </a:xfrm>
+            <a:prstGeom prst="roundRect">
+              <a:avLst/>
+            </a:prstGeom>
+          </p:spPr>
+          <p:style>
+            <a:lnRef idx="0">
+              <a:schemeClr val="accent5"/>
+            </a:lnRef>
+            <a:fillRef idx="3">
+              <a:schemeClr val="accent5"/>
+            </a:fillRef>
+            <a:effectRef idx="3">
+              <a:schemeClr val="accent5"/>
+            </a:effectRef>
+            <a:fontRef idx="minor">
+              <a:schemeClr val="lt1"/>
+            </a:fontRef>
+          </p:style>
+          <p:txBody>
+            <a:bodyPr rtlCol="0" anchor="ctr"/>
+            <a:lstStyle/>
+            <a:p>
+              <a:pPr algn="ctr"/>
+              <a:r>
+                <a:rPr lang="en-US" sz="2400" b="1" dirty="0"/>
+                <a:t>?</a:t>
+              </a:r>
+              <a:endParaRPr lang="en-US" sz="2400" b="1" dirty="0"/>
+            </a:p>
+          </p:txBody>
+        </p:sp>
+        <p:sp>
+          <p:nvSpPr>
+            <p:cNvPr id="31" name="Rounded Rectangle 30"/>
+            <p:cNvSpPr/>
+            <p:nvPr/>
+          </p:nvSpPr>
+          <p:spPr>
+            <a:xfrm>
+              <a:off x="4219024" y="4895381"/>
+              <a:ext cx="1035017" cy="1089495"/>
+            </a:xfrm>
+            <a:prstGeom prst="roundRect">
+              <a:avLst/>
+            </a:prstGeom>
+          </p:spPr>
+          <p:style>
+            <a:lnRef idx="0">
+              <a:schemeClr val="accent5"/>
+            </a:lnRef>
+            <a:fillRef idx="3">
+              <a:schemeClr val="accent5"/>
+            </a:fillRef>
+            <a:effectRef idx="3">
+              <a:schemeClr val="accent5"/>
+            </a:effectRef>
+            <a:fontRef idx="minor">
+              <a:schemeClr val="lt1"/>
+            </a:fontRef>
+          </p:style>
+          <p:txBody>
+            <a:bodyPr rtlCol="0" anchor="ctr"/>
+            <a:lstStyle/>
+            <a:p>
+              <a:pPr algn="ctr"/>
+              <a:r>
+                <a:rPr lang="en-US" sz="2400" b="1" dirty="0"/>
+                <a:t>?</a:t>
+              </a:r>
+              <a:endParaRPr lang="en-US" sz="2400" b="1" dirty="0"/>
+            </a:p>
+          </p:txBody>
+        </p:sp>
+        <p:sp>
+          <p:nvSpPr>
+            <p:cNvPr id="32" name="Rounded Rectangle 31"/>
+            <p:cNvSpPr/>
+            <p:nvPr/>
+          </p:nvSpPr>
+          <p:spPr>
+            <a:xfrm>
+              <a:off x="5548404" y="4908633"/>
+              <a:ext cx="1035017" cy="1089495"/>
+            </a:xfrm>
+            <a:prstGeom prst="roundRect">
+              <a:avLst/>
+            </a:prstGeom>
+          </p:spPr>
+          <p:style>
+            <a:lnRef idx="0">
+              <a:schemeClr val="accent5"/>
+            </a:lnRef>
+            <a:fillRef idx="3">
+              <a:schemeClr val="accent5"/>
+            </a:fillRef>
+            <a:effectRef idx="3">
+              <a:schemeClr val="accent5"/>
+            </a:effectRef>
+            <a:fontRef idx="minor">
+              <a:schemeClr val="lt1"/>
+            </a:fontRef>
+          </p:style>
+          <p:txBody>
+            <a:bodyPr rtlCol="0" anchor="ctr"/>
+            <a:lstStyle/>
+            <a:p>
+              <a:pPr algn="ctr"/>
+              <a:r>
+                <a:rPr lang="en-US" sz="2400" b="1" dirty="0"/>
+                <a:t>?</a:t>
+              </a:r>
+              <a:endParaRPr lang="en-US" sz="2400" b="1" dirty="0"/>
+            </a:p>
+          </p:txBody>
+        </p:sp>
+        <p:sp>
+          <p:nvSpPr>
+            <p:cNvPr id="33" name="Rounded Rectangle 32"/>
+            <p:cNvSpPr/>
+            <p:nvPr/>
+          </p:nvSpPr>
+          <p:spPr>
+            <a:xfrm>
+              <a:off x="6844550" y="4908633"/>
+              <a:ext cx="1035017" cy="1089495"/>
+            </a:xfrm>
+            <a:prstGeom prst="roundRect">
+              <a:avLst/>
+            </a:prstGeom>
+          </p:spPr>
+          <p:style>
+            <a:lnRef idx="0">
+              <a:schemeClr val="accent5"/>
+            </a:lnRef>
+            <a:fillRef idx="3">
+              <a:schemeClr val="accent5"/>
+            </a:fillRef>
+            <a:effectRef idx="3">
+              <a:schemeClr val="accent5"/>
+            </a:effectRef>
+            <a:fontRef idx="minor">
+              <a:schemeClr val="lt1"/>
+            </a:fontRef>
+          </p:style>
+          <p:txBody>
+            <a:bodyPr rtlCol="0" anchor="ctr"/>
+            <a:lstStyle/>
+            <a:p>
+              <a:pPr algn="ctr"/>
+              <a:r>
+                <a:rPr lang="en-US" sz="2400" b="1" dirty="0"/>
+                <a:t>?</a:t>
+              </a:r>
+              <a:endParaRPr lang="en-US" sz="2400" b="1" dirty="0"/>
+            </a:p>
+          </p:txBody>
+        </p:sp>
+        <p:sp>
+          <p:nvSpPr>
+            <p:cNvPr id="34" name="Rounded Rectangle 33"/>
+            <p:cNvSpPr/>
+            <p:nvPr/>
+          </p:nvSpPr>
+          <p:spPr>
+            <a:xfrm>
+              <a:off x="8140696" y="4897132"/>
+              <a:ext cx="1035017" cy="1089495"/>
+            </a:xfrm>
+            <a:prstGeom prst="roundRect">
+              <a:avLst/>
+            </a:prstGeom>
+          </p:spPr>
+          <p:style>
+            <a:lnRef idx="0">
+              <a:schemeClr val="accent5"/>
+            </a:lnRef>
+            <a:fillRef idx="3">
+              <a:schemeClr val="accent5"/>
+            </a:fillRef>
+            <a:effectRef idx="3">
+              <a:schemeClr val="accent5"/>
+            </a:effectRef>
+            <a:fontRef idx="minor">
+              <a:schemeClr val="lt1"/>
+            </a:fontRef>
+          </p:style>
+          <p:txBody>
+            <a:bodyPr rtlCol="0" anchor="ctr"/>
+            <a:lstStyle/>
+            <a:p>
+              <a:pPr algn="ctr"/>
+              <a:r>
+                <a:rPr lang="en-US" sz="2400" b="1" dirty="0"/>
+                <a:t>?</a:t>
+              </a:r>
+              <a:endParaRPr lang="en-US" sz="2400" b="1" dirty="0"/>
+            </a:p>
+          </p:txBody>
+        </p:sp>
+        <p:sp>
+          <p:nvSpPr>
+            <p:cNvPr id="18" name="5-Point Star 17"/>
+            <p:cNvSpPr/>
+            <p:nvPr/>
+          </p:nvSpPr>
+          <p:spPr>
+            <a:xfrm>
+              <a:off x="5877810" y="1523339"/>
+              <a:ext cx="329180" cy="314853"/>
+            </a:xfrm>
+            <a:prstGeom prst="star5">
+              <a:avLst/>
+            </a:prstGeom>
+          </p:spPr>
+          <p:style>
+            <a:lnRef idx="1">
+              <a:schemeClr val="accent4"/>
+            </a:lnRef>
+            <a:fillRef idx="3">
+              <a:schemeClr val="accent4"/>
+            </a:fillRef>
+            <a:effectRef idx="2">
+              <a:schemeClr val="accent4"/>
+            </a:effectRef>
+            <a:fontRef idx="minor">
+              <a:schemeClr val="lt1"/>
+            </a:fontRef>
+          </p:style>
+          <p:txBody>
+            <a:bodyPr rtlCol="0" anchor="ctr"/>
+            <a:lstStyle/>
+            <a:p>
+              <a:pPr algn="ctr"/>
+              <a:endParaRPr lang="en-US"/>
+            </a:p>
+          </p:txBody>
+        </p:sp>
+      </p:grpSp>
+    </p:spTree>
+    <p:extLst>
+      <p:ext uri="{BB962C8B-B14F-4D97-AF65-F5344CB8AC3E}">
+        <p14:creationId xmlns:p14="http://schemas.microsoft.com/office/powerpoint/2010/main" val="2939705973"/>
       </p:ext>
     </p:extLst>
   </p:cSld>

</xml_diff>